<commit_message>
Clarify requirements definition workflow
</commit_message>
<xml_diff>
--- a/三角比改訂版_改善版.pptx
+++ b/三角比改訂版_改善版.pptx
@@ -211,7 +211,7 @@
             <a:fld id="{3D383421-03FE-4117-BD4D-FFF3E7F07C3B}" type="datetimeFigureOut">
               <a:rPr kumimoji="1" lang="ja-JP" altLang="en-US" smtClean="0"/>
               <a:pPr/>
-              <a:t>2026/5/31</a:t>
+              <a:t>2026/6/7</a:t>
             </a:fld>
             <a:endParaRPr kumimoji="1" lang="ja-JP" altLang="en-US"/>
           </a:p>
@@ -770,7 +770,7 @@
             <a:fld id="{BFAA404C-07B7-49A1-B06A-605A7C46FBE3}" type="datetimeFigureOut">
               <a:rPr kumimoji="1" lang="ja-JP" altLang="en-US" smtClean="0"/>
               <a:pPr/>
-              <a:t>2026/5/31</a:t>
+              <a:t>2026/6/7</a:t>
             </a:fld>
             <a:endParaRPr kumimoji="1" lang="ja-JP" altLang="en-US"/>
           </a:p>
@@ -967,7 +967,7 @@
             <a:fld id="{BFAA404C-07B7-49A1-B06A-605A7C46FBE3}" type="datetimeFigureOut">
               <a:rPr kumimoji="1" lang="ja-JP" altLang="en-US" smtClean="0"/>
               <a:pPr/>
-              <a:t>2026/5/31</a:t>
+              <a:t>2026/6/7</a:t>
             </a:fld>
             <a:endParaRPr kumimoji="1" lang="ja-JP" altLang="en-US"/>
           </a:p>
@@ -1174,7 +1174,7 @@
             <a:fld id="{BFAA404C-07B7-49A1-B06A-605A7C46FBE3}" type="datetimeFigureOut">
               <a:rPr kumimoji="1" lang="ja-JP" altLang="en-US" smtClean="0"/>
               <a:pPr/>
-              <a:t>2026/5/31</a:t>
+              <a:t>2026/6/7</a:t>
             </a:fld>
             <a:endParaRPr kumimoji="1" lang="ja-JP" altLang="en-US"/>
           </a:p>
@@ -1371,7 +1371,7 @@
             <a:fld id="{BFAA404C-07B7-49A1-B06A-605A7C46FBE3}" type="datetimeFigureOut">
               <a:rPr kumimoji="1" lang="ja-JP" altLang="en-US" smtClean="0"/>
               <a:pPr/>
-              <a:t>2026/5/31</a:t>
+              <a:t>2026/6/7</a:t>
             </a:fld>
             <a:endParaRPr kumimoji="1" lang="ja-JP" altLang="en-US"/>
           </a:p>
@@ -1613,7 +1613,7 @@
             <a:fld id="{BFAA404C-07B7-49A1-B06A-605A7C46FBE3}" type="datetimeFigureOut">
               <a:rPr kumimoji="1" lang="ja-JP" altLang="en-US" smtClean="0"/>
               <a:pPr/>
-              <a:t>2026/5/31</a:t>
+              <a:t>2026/6/7</a:t>
             </a:fld>
             <a:endParaRPr kumimoji="1" lang="ja-JP" altLang="en-US"/>
           </a:p>
@@ -1959,7 +1959,7 @@
             <a:fld id="{BFAA404C-07B7-49A1-B06A-605A7C46FBE3}" type="datetimeFigureOut">
               <a:rPr kumimoji="1" lang="ja-JP" altLang="en-US" smtClean="0"/>
               <a:pPr/>
-              <a:t>2026/5/31</a:t>
+              <a:t>2026/6/7</a:t>
             </a:fld>
             <a:endParaRPr kumimoji="1" lang="ja-JP" altLang="en-US"/>
           </a:p>
@@ -2439,7 +2439,7 @@
             <a:fld id="{BFAA404C-07B7-49A1-B06A-605A7C46FBE3}" type="datetimeFigureOut">
               <a:rPr kumimoji="1" lang="ja-JP" altLang="en-US" smtClean="0"/>
               <a:pPr/>
-              <a:t>2026/5/31</a:t>
+              <a:t>2026/6/7</a:t>
             </a:fld>
             <a:endParaRPr kumimoji="1" lang="ja-JP" altLang="en-US"/>
           </a:p>
@@ -2553,7 +2553,7 @@
             <a:fld id="{BFAA404C-07B7-49A1-B06A-605A7C46FBE3}" type="datetimeFigureOut">
               <a:rPr kumimoji="1" lang="ja-JP" altLang="en-US" smtClean="0"/>
               <a:pPr/>
-              <a:t>2026/5/31</a:t>
+              <a:t>2026/6/7</a:t>
             </a:fld>
             <a:endParaRPr kumimoji="1" lang="ja-JP" altLang="en-US"/>
           </a:p>
@@ -2645,7 +2645,7 @@
             <a:fld id="{BFAA404C-07B7-49A1-B06A-605A7C46FBE3}" type="datetimeFigureOut">
               <a:rPr kumimoji="1" lang="ja-JP" altLang="en-US" smtClean="0"/>
               <a:pPr/>
-              <a:t>2026/5/31</a:t>
+              <a:t>2026/6/7</a:t>
             </a:fld>
             <a:endParaRPr kumimoji="1" lang="ja-JP" altLang="en-US"/>
           </a:p>
@@ -2949,7 +2949,7 @@
             <a:fld id="{BFAA404C-07B7-49A1-B06A-605A7C46FBE3}" type="datetimeFigureOut">
               <a:rPr kumimoji="1" lang="ja-JP" altLang="en-US" smtClean="0"/>
               <a:pPr/>
-              <a:t>2026/5/31</a:t>
+              <a:t>2026/6/7</a:t>
             </a:fld>
             <a:endParaRPr kumimoji="1" lang="ja-JP" altLang="en-US"/>
           </a:p>
@@ -3198,7 +3198,7 @@
             <a:fld id="{BFAA404C-07B7-49A1-B06A-605A7C46FBE3}" type="datetimeFigureOut">
               <a:rPr kumimoji="1" lang="ja-JP" altLang="en-US" smtClean="0"/>
               <a:pPr/>
-              <a:t>2026/5/31</a:t>
+              <a:t>2026/6/7</a:t>
             </a:fld>
             <a:endParaRPr kumimoji="1" lang="ja-JP" altLang="en-US"/>
           </a:p>
@@ -3438,7 +3438,7 @@
             <a:fld id="{BFAA404C-07B7-49A1-B06A-605A7C46FBE3}" type="datetimeFigureOut">
               <a:rPr kumimoji="1" lang="ja-JP" altLang="en-US" smtClean="0"/>
               <a:pPr/>
-              <a:t>2026/5/31</a:t>
+              <a:t>2026/6/7</a:t>
             </a:fld>
             <a:endParaRPr kumimoji="1" lang="ja-JP" altLang="en-US"/>
           </a:p>
@@ -13672,7 +13672,7 @@
           <p:cNvPr id="2" name="テキスト ボックス 1">
             <a:extLst>
               <a:ext uri="{FF2B5EF4-FFF2-40B4-BE49-F238E27FC236}">
-                <a16:creationId xmlns:a16="http://schemas.microsoft.com/office/drawing/2014/main" id="{9063A22F-5257-681A-3DB1-94503A83F5FA}"/>
+                <a16:creationId xmlns:a16="http://schemas.microsoft.com/office/drawing/2014/main" id="{96F94748-C69A-129D-AA9A-94F3E47FBBB6}"/>
               </a:ext>
             </a:extLst>
           </p:cNvPr>
@@ -13696,7 +13696,7 @@
           <a:lstStyle/>
           <a:p>
             <a:r>
-              <a:rPr kumimoji="1" lang="ja-JP" altLang="en-US" sz="2200" b="1" dirty="0">
+              <a:rPr kumimoji="1" lang="ja-JP" altLang="en-US" sz="2200" b="1">
                 <a:solidFill>
                   <a:srgbClr val="141414"/>
                 </a:solidFill>
@@ -13712,7 +13712,7 @@
           <p:cNvPr id="3" name="テキスト ボックス 2">
             <a:extLst>
               <a:ext uri="{FF2B5EF4-FFF2-40B4-BE49-F238E27FC236}">
-                <a16:creationId xmlns:a16="http://schemas.microsoft.com/office/drawing/2014/main" id="{86130F25-B1FB-1794-E178-E0CA4BDA7A5E}"/>
+                <a16:creationId xmlns:a16="http://schemas.microsoft.com/office/drawing/2014/main" id="{1BC9C1ED-780F-2B7B-7C03-F5B9A8F4A5B4}"/>
               </a:ext>
             </a:extLst>
           </p:cNvPr>
@@ -13752,7 +13752,7 @@
           <p:cNvPr id="4" name="正方形/長方形 3">
             <a:extLst>
               <a:ext uri="{FF2B5EF4-FFF2-40B4-BE49-F238E27FC236}">
-                <a16:creationId xmlns:a16="http://schemas.microsoft.com/office/drawing/2014/main" id="{3A21FB48-EF59-F72B-E742-E59BA0DF5917}"/>
+                <a16:creationId xmlns:a16="http://schemas.microsoft.com/office/drawing/2014/main" id="{09E10E93-B4DC-F84F-DBCF-0D805486C7CD}"/>
               </a:ext>
             </a:extLst>
           </p:cNvPr>
@@ -13833,7 +13833,7 @@
           <p:cNvPr id="5" name="正方形/長方形 4">
             <a:extLst>
               <a:ext uri="{FF2B5EF4-FFF2-40B4-BE49-F238E27FC236}">
-                <a16:creationId xmlns:a16="http://schemas.microsoft.com/office/drawing/2014/main" id="{8F4E349D-BD8B-7534-46ED-9515508F31CF}"/>
+                <a16:creationId xmlns:a16="http://schemas.microsoft.com/office/drawing/2014/main" id="{3B12545A-50B3-C917-543A-C5C0B394D9F3}"/>
               </a:ext>
             </a:extLst>
           </p:cNvPr>
@@ -13965,7 +13965,7 @@
           <p:cNvPr id="6" name="正方形/長方形 5">
             <a:extLst>
               <a:ext uri="{FF2B5EF4-FFF2-40B4-BE49-F238E27FC236}">
-                <a16:creationId xmlns:a16="http://schemas.microsoft.com/office/drawing/2014/main" id="{A9E0E42F-48FC-FAB1-9DD5-D501C469C52F}"/>
+                <a16:creationId xmlns:a16="http://schemas.microsoft.com/office/drawing/2014/main" id="{E44EA0DA-C5CE-01F3-4D2F-AD005342D0E7}"/>
               </a:ext>
             </a:extLst>
           </p:cNvPr>
@@ -14088,7 +14088,7 @@
           <p:cNvPr id="7" name="正方形/長方形 6">
             <a:extLst>
               <a:ext uri="{FF2B5EF4-FFF2-40B4-BE49-F238E27FC236}">
-                <a16:creationId xmlns:a16="http://schemas.microsoft.com/office/drawing/2014/main" id="{F81EDFD6-6F11-43B6-C99E-90251EB6351B}"/>
+                <a16:creationId xmlns:a16="http://schemas.microsoft.com/office/drawing/2014/main" id="{39EF8787-3ED1-CCE4-9D0E-83E4964F169F}"/>
               </a:ext>
             </a:extLst>
           </p:cNvPr>
@@ -14223,7 +14223,7 @@
           <p:cNvPr id="8" name="楕円 7">
             <a:extLst>
               <a:ext uri="{FF2B5EF4-FFF2-40B4-BE49-F238E27FC236}">
-                <a16:creationId xmlns:a16="http://schemas.microsoft.com/office/drawing/2014/main" id="{3728945C-FD69-65E5-A31F-27A287BDDD91}"/>
+                <a16:creationId xmlns:a16="http://schemas.microsoft.com/office/drawing/2014/main" id="{F264EF95-29D9-1AFF-D72E-6F6B8A0A72F9}"/>
               </a:ext>
             </a:extLst>
           </p:cNvPr>
@@ -14279,7 +14279,7 @@
           <p:cNvPr id="9" name="直線コネクタ 8">
             <a:extLst>
               <a:ext uri="{FF2B5EF4-FFF2-40B4-BE49-F238E27FC236}">
-                <a16:creationId xmlns:a16="http://schemas.microsoft.com/office/drawing/2014/main" id="{CC6CF077-DB6D-4F5B-12AF-8C9AE9DD6096}"/>
+                <a16:creationId xmlns:a16="http://schemas.microsoft.com/office/drawing/2014/main" id="{69456142-9184-73DF-28E8-8689A4E04C85}"/>
               </a:ext>
             </a:extLst>
           </p:cNvPr>
@@ -14321,7 +14321,7 @@
           <p:cNvPr id="10" name="直線コネクタ 9">
             <a:extLst>
               <a:ext uri="{FF2B5EF4-FFF2-40B4-BE49-F238E27FC236}">
-                <a16:creationId xmlns:a16="http://schemas.microsoft.com/office/drawing/2014/main" id="{7E250F54-0FB1-6203-C4D2-D303159B1CE1}"/>
+                <a16:creationId xmlns:a16="http://schemas.microsoft.com/office/drawing/2014/main" id="{8E8C9815-83EF-7407-3D81-7DF04E70E33C}"/>
               </a:ext>
             </a:extLst>
           </p:cNvPr>
@@ -14363,7 +14363,7 @@
           <p:cNvPr id="11" name="直線コネクタ 10">
             <a:extLst>
               <a:ext uri="{FF2B5EF4-FFF2-40B4-BE49-F238E27FC236}">
-                <a16:creationId xmlns:a16="http://schemas.microsoft.com/office/drawing/2014/main" id="{9548BDCC-5581-370D-0291-77E1C9D9A263}"/>
+                <a16:creationId xmlns:a16="http://schemas.microsoft.com/office/drawing/2014/main" id="{3AAD223A-381C-D7CB-BE8E-762F91F5C2E7}"/>
               </a:ext>
             </a:extLst>
           </p:cNvPr>
@@ -14372,8 +14372,8 @@
         </p:nvCxnSpPr>
         <p:spPr>
           <a:xfrm flipV="1">
-            <a:off x="5016500" y="2006600"/>
-            <a:ext cx="1181100" cy="977900"/>
+            <a:off x="5016500" y="1993900"/>
+            <a:ext cx="990600" cy="990600"/>
           </a:xfrm>
           <a:prstGeom prst="line">
             <a:avLst/>
@@ -14404,7 +14404,7 @@
           <p:cNvPr id="12" name="直線コネクタ 11">
             <a:extLst>
               <a:ext uri="{FF2B5EF4-FFF2-40B4-BE49-F238E27FC236}">
-                <a16:creationId xmlns:a16="http://schemas.microsoft.com/office/drawing/2014/main" id="{269B9F18-4C7B-F462-3EFA-93729F20F0CD}"/>
+                <a16:creationId xmlns:a16="http://schemas.microsoft.com/office/drawing/2014/main" id="{B1497515-92A4-B663-2FF3-1A9BAFC6DA92}"/>
               </a:ext>
             </a:extLst>
           </p:cNvPr>
@@ -14413,8 +14413,8 @@
         </p:nvCxnSpPr>
         <p:spPr>
           <a:xfrm>
-            <a:off x="6197600" y="2006600"/>
-            <a:ext cx="0" cy="977900"/>
+            <a:off x="6007100" y="1993900"/>
+            <a:ext cx="0" cy="990600"/>
           </a:xfrm>
           <a:prstGeom prst="line">
             <a:avLst/>
@@ -14446,7 +14446,7 @@
           <p:cNvPr id="13" name="直線コネクタ 12">
             <a:extLst>
               <a:ext uri="{FF2B5EF4-FFF2-40B4-BE49-F238E27FC236}">
-                <a16:creationId xmlns:a16="http://schemas.microsoft.com/office/drawing/2014/main" id="{C2F8A351-D7A1-31D7-D798-87ACB59EB1FB}"/>
+                <a16:creationId xmlns:a16="http://schemas.microsoft.com/office/drawing/2014/main" id="{A4107183-C23A-1912-44A7-3409D355CABA}"/>
               </a:ext>
             </a:extLst>
           </p:cNvPr>
@@ -14456,7 +14456,7 @@
         <p:spPr>
           <a:xfrm>
             <a:off x="5016500" y="2984500"/>
-            <a:ext cx="1181100" cy="0"/>
+            <a:ext cx="990600" cy="0"/>
           </a:xfrm>
           <a:prstGeom prst="line">
             <a:avLst/>
@@ -14482,12 +14482,217 @@
           </a:fontRef>
         </p:style>
       </p:cxnSp>
+      <p:cxnSp>
+        <p:nvCxnSpPr>
+          <p:cNvPr id="14" name="直線コネクタ 13">
+            <a:extLst>
+              <a:ext uri="{FF2B5EF4-FFF2-40B4-BE49-F238E27FC236}">
+                <a16:creationId xmlns:a16="http://schemas.microsoft.com/office/drawing/2014/main" id="{618CC747-16A8-3616-CFA9-B9F41960F75C}"/>
+              </a:ext>
+            </a:extLst>
+          </p:cNvPr>
+          <p:cNvCxnSpPr/>
+          <p:nvPr/>
+        </p:nvCxnSpPr>
+        <p:spPr>
+          <a:xfrm flipH="1" flipV="1">
+            <a:off x="5493159" y="2909005"/>
+            <a:ext cx="5941" cy="75495"/>
+          </a:xfrm>
+          <a:prstGeom prst="line">
+            <a:avLst/>
+          </a:prstGeom>
+          <a:ln w="15240">
+            <a:solidFill>
+              <a:srgbClr val="141414"/>
+            </a:solidFill>
+          </a:ln>
+        </p:spPr>
+        <p:style>
+          <a:lnRef idx="1">
+            <a:schemeClr val="accent1"/>
+          </a:lnRef>
+          <a:fillRef idx="0">
+            <a:schemeClr val="accent1"/>
+          </a:fillRef>
+          <a:effectRef idx="0">
+            <a:schemeClr val="accent1"/>
+          </a:effectRef>
+          <a:fontRef idx="minor">
+            <a:schemeClr val="tx1"/>
+          </a:fontRef>
+        </p:style>
+      </p:cxnSp>
+      <p:cxnSp>
+        <p:nvCxnSpPr>
+          <p:cNvPr id="15" name="直線コネクタ 14">
+            <a:extLst>
+              <a:ext uri="{FF2B5EF4-FFF2-40B4-BE49-F238E27FC236}">
+                <a16:creationId xmlns:a16="http://schemas.microsoft.com/office/drawing/2014/main" id="{909FF06A-6F28-AA83-6334-59C29AD86053}"/>
+              </a:ext>
+            </a:extLst>
+          </p:cNvPr>
+          <p:cNvCxnSpPr/>
+          <p:nvPr/>
+        </p:nvCxnSpPr>
+        <p:spPr>
+          <a:xfrm flipH="1" flipV="1">
+            <a:off x="5475480" y="2835368"/>
+            <a:ext cx="17679" cy="73637"/>
+          </a:xfrm>
+          <a:prstGeom prst="line">
+            <a:avLst/>
+          </a:prstGeom>
+          <a:ln w="15240">
+            <a:solidFill>
+              <a:srgbClr val="141414"/>
+            </a:solidFill>
+          </a:ln>
+        </p:spPr>
+        <p:style>
+          <a:lnRef idx="1">
+            <a:schemeClr val="accent1"/>
+          </a:lnRef>
+          <a:fillRef idx="0">
+            <a:schemeClr val="accent1"/>
+          </a:fillRef>
+          <a:effectRef idx="0">
+            <a:schemeClr val="accent1"/>
+          </a:effectRef>
+          <a:fontRef idx="minor">
+            <a:schemeClr val="tx1"/>
+          </a:fontRef>
+        </p:style>
+      </p:cxnSp>
+      <p:cxnSp>
+        <p:nvCxnSpPr>
+          <p:cNvPr id="16" name="直線コネクタ 15">
+            <a:extLst>
+              <a:ext uri="{FF2B5EF4-FFF2-40B4-BE49-F238E27FC236}">
+                <a16:creationId xmlns:a16="http://schemas.microsoft.com/office/drawing/2014/main" id="{86215173-BB57-B392-284B-E03A90B34869}"/>
+              </a:ext>
+            </a:extLst>
+          </p:cNvPr>
+          <p:cNvCxnSpPr/>
+          <p:nvPr/>
+        </p:nvCxnSpPr>
+        <p:spPr>
+          <a:xfrm flipH="1" flipV="1">
+            <a:off x="5446500" y="2765404"/>
+            <a:ext cx="28980" cy="69964"/>
+          </a:xfrm>
+          <a:prstGeom prst="line">
+            <a:avLst/>
+          </a:prstGeom>
+          <a:ln w="15240">
+            <a:solidFill>
+              <a:srgbClr val="141414"/>
+            </a:solidFill>
+          </a:ln>
+        </p:spPr>
+        <p:style>
+          <a:lnRef idx="1">
+            <a:schemeClr val="accent1"/>
+          </a:lnRef>
+          <a:fillRef idx="0">
+            <a:schemeClr val="accent1"/>
+          </a:fillRef>
+          <a:effectRef idx="0">
+            <a:schemeClr val="accent1"/>
+          </a:effectRef>
+          <a:fontRef idx="minor">
+            <a:schemeClr val="tx1"/>
+          </a:fontRef>
+        </p:style>
+      </p:cxnSp>
+      <p:cxnSp>
+        <p:nvCxnSpPr>
+          <p:cNvPr id="17" name="直線コネクタ 16">
+            <a:extLst>
+              <a:ext uri="{FF2B5EF4-FFF2-40B4-BE49-F238E27FC236}">
+                <a16:creationId xmlns:a16="http://schemas.microsoft.com/office/drawing/2014/main" id="{AFA5E7A4-73DE-71EB-7146-D7B528868A29}"/>
+              </a:ext>
+            </a:extLst>
+          </p:cNvPr>
+          <p:cNvCxnSpPr/>
+          <p:nvPr/>
+        </p:nvCxnSpPr>
+        <p:spPr>
+          <a:xfrm flipH="1" flipV="1">
+            <a:off x="5406932" y="2700835"/>
+            <a:ext cx="39568" cy="64569"/>
+          </a:xfrm>
+          <a:prstGeom prst="line">
+            <a:avLst/>
+          </a:prstGeom>
+          <a:ln w="15240">
+            <a:solidFill>
+              <a:srgbClr val="141414"/>
+            </a:solidFill>
+          </a:ln>
+        </p:spPr>
+        <p:style>
+          <a:lnRef idx="1">
+            <a:schemeClr val="accent1"/>
+          </a:lnRef>
+          <a:fillRef idx="0">
+            <a:schemeClr val="accent1"/>
+          </a:fillRef>
+          <a:effectRef idx="0">
+            <a:schemeClr val="accent1"/>
+          </a:effectRef>
+          <a:fontRef idx="minor">
+            <a:schemeClr val="tx1"/>
+          </a:fontRef>
+        </p:style>
+      </p:cxnSp>
+      <p:cxnSp>
+        <p:nvCxnSpPr>
+          <p:cNvPr id="18" name="直線コネクタ 17">
+            <a:extLst>
+              <a:ext uri="{FF2B5EF4-FFF2-40B4-BE49-F238E27FC236}">
+                <a16:creationId xmlns:a16="http://schemas.microsoft.com/office/drawing/2014/main" id="{A2C9B182-3087-9D31-21B5-25DC8963EEAE}"/>
+              </a:ext>
+            </a:extLst>
+          </p:cNvPr>
+          <p:cNvCxnSpPr/>
+          <p:nvPr/>
+        </p:nvCxnSpPr>
+        <p:spPr>
+          <a:xfrm flipH="1" flipV="1">
+            <a:off x="5357750" y="2643250"/>
+            <a:ext cx="49182" cy="57585"/>
+          </a:xfrm>
+          <a:prstGeom prst="line">
+            <a:avLst/>
+          </a:prstGeom>
+          <a:ln w="15240">
+            <a:solidFill>
+              <a:srgbClr val="141414"/>
+            </a:solidFill>
+          </a:ln>
+        </p:spPr>
+        <p:style>
+          <a:lnRef idx="1">
+            <a:schemeClr val="accent1"/>
+          </a:lnRef>
+          <a:fillRef idx="0">
+            <a:schemeClr val="accent1"/>
+          </a:fillRef>
+          <a:effectRef idx="0">
+            <a:schemeClr val="accent1"/>
+          </a:effectRef>
+          <a:fontRef idx="minor">
+            <a:schemeClr val="tx1"/>
+          </a:fontRef>
+        </p:style>
+      </p:cxnSp>
       <p:sp>
         <p:nvSpPr>
-          <p:cNvPr id="14" name="楕円 13">
+          <p:cNvPr id="19" name="楕円 18">
             <a:extLst>
               <a:ext uri="{FF2B5EF4-FFF2-40B4-BE49-F238E27FC236}">
-                <a16:creationId xmlns:a16="http://schemas.microsoft.com/office/drawing/2014/main" id="{59C5042D-0D87-DA30-2FF5-257FC6A1975C}"/>
+                <a16:creationId xmlns:a16="http://schemas.microsoft.com/office/drawing/2014/main" id="{94DA8224-895F-30F4-32C7-9DDBA1C4A8EA}"/>
               </a:ext>
             </a:extLst>
           </p:cNvPr>
@@ -14496,7 +14701,7 @@
         </p:nvSpPr>
         <p:spPr>
           <a:xfrm>
-            <a:off x="6134100" y="1943100"/>
+            <a:off x="5943600" y="1930400"/>
             <a:ext cx="127000" cy="127000"/>
           </a:xfrm>
           <a:prstGeom prst="ellipse">
@@ -14550,10 +14755,160 @@
       </p:sp>
       <p:sp>
         <p:nvSpPr>
-          <p:cNvPr id="15" name="テキスト ボックス 14">
+          <p:cNvPr id="20" name="正方形/長方形 19">
             <a:extLst>
               <a:ext uri="{FF2B5EF4-FFF2-40B4-BE49-F238E27FC236}">
-                <a16:creationId xmlns:a16="http://schemas.microsoft.com/office/drawing/2014/main" id="{F6C0135C-0EB7-AC4E-E787-138779894033}"/>
+                <a16:creationId xmlns:a16="http://schemas.microsoft.com/office/drawing/2014/main" id="{D8AB80FD-09A5-7ADE-9927-1C4D83876D9D}"/>
+              </a:ext>
+            </a:extLst>
+          </p:cNvPr>
+          <p:cNvSpPr/>
+          <p:nvPr/>
+        </p:nvSpPr>
+        <p:spPr>
+          <a:xfrm>
+            <a:off x="5448300" y="1689100"/>
+            <a:ext cx="1397000" cy="266700"/>
+          </a:xfrm>
+          <a:prstGeom prst="rect">
+            <a:avLst/>
+          </a:prstGeom>
+          <a:solidFill>
+            <a:srgbClr val="FFFFFF">
+              <a:alpha val="92000"/>
+            </a:srgbClr>
+          </a:solidFill>
+          <a:ln w="25400" cap="flat" cmpd="sng" algn="ctr">
+            <a:noFill/>
+            <a:prstDash val="solid"/>
+          </a:ln>
+          <a:effectLst/>
+          <a:extLst>
+            <a:ext uri="{91240B29-F687-4F45-9708-019B960494DF}">
+              <a14:hiddenLine xmlns:a14="http://schemas.microsoft.com/office/drawing/2010/main" w="25400" cap="flat" cmpd="sng" algn="ctr">
+                <a:solidFill>
+                  <a:schemeClr val="accent1">
+                    <a:shade val="50000"/>
+                  </a:schemeClr>
+                </a:solidFill>
+                <a:prstDash val="solid"/>
+              </a14:hiddenLine>
+            </a:ext>
+          </a:extLst>
+        </p:spPr>
+        <p:style>
+          <a:lnRef idx="2">
+            <a:schemeClr val="accent1">
+              <a:shade val="50000"/>
+            </a:schemeClr>
+          </a:lnRef>
+          <a:fillRef idx="1">
+            <a:schemeClr val="accent1"/>
+          </a:fillRef>
+          <a:effectRef idx="0">
+            <a:schemeClr val="accent1"/>
+          </a:effectRef>
+          <a:fontRef idx="minor">
+            <a:schemeClr val="lt1"/>
+          </a:fontRef>
+        </p:style>
+        <p:txBody>
+          <a:bodyPr lIns="63500" tIns="25400" rIns="63500" bIns="25400" rtlCol="0" anchor="ctr"/>
+          <a:lstStyle/>
+          <a:p>
+            <a:pPr algn="ctr"/>
+            <a:r>
+              <a:rPr kumimoji="1" lang="en-US" altLang="ja-JP" sz="1100" b="1">
+                <a:solidFill>
+                  <a:srgbClr val="141414"/>
+                </a:solidFill>
+                <a:latin typeface="Yu Gothic" panose="020B0400000000000000" pitchFamily="50" charset="-128"/>
+              </a:rPr>
+              <a:t>(cos</a:t>
+            </a:r>
+            <a:r>
+              <a:rPr kumimoji="1" lang="el-GR" altLang="ja-JP" sz="1100" b="1">
+                <a:solidFill>
+                  <a:srgbClr val="141414"/>
+                </a:solidFill>
+                <a:latin typeface="Yu Gothic" panose="020B0400000000000000" pitchFamily="50" charset="-128"/>
+              </a:rPr>
+              <a:t>θ, </a:t>
+            </a:r>
+            <a:r>
+              <a:rPr kumimoji="1" lang="en-US" altLang="ja-JP" sz="1100" b="1">
+                <a:solidFill>
+                  <a:srgbClr val="141414"/>
+                </a:solidFill>
+                <a:latin typeface="Yu Gothic" panose="020B0400000000000000" pitchFamily="50" charset="-128"/>
+              </a:rPr>
+              <a:t>sin</a:t>
+            </a:r>
+            <a:r>
+              <a:rPr kumimoji="1" lang="el-GR" altLang="ja-JP" sz="1100" b="1">
+                <a:solidFill>
+                  <a:srgbClr val="141414"/>
+                </a:solidFill>
+                <a:latin typeface="Yu Gothic" panose="020B0400000000000000" pitchFamily="50" charset="-128"/>
+              </a:rPr>
+              <a:t>θ)</a:t>
+            </a:r>
+            <a:endParaRPr kumimoji="1" lang="ja-JP" altLang="en-US" sz="1100" b="1">
+              <a:solidFill>
+                <a:srgbClr val="141414"/>
+              </a:solidFill>
+              <a:latin typeface="Yu Gothic" panose="020B0400000000000000" pitchFamily="50" charset="-128"/>
+            </a:endParaRPr>
+          </a:p>
+        </p:txBody>
+      </p:sp>
+      <p:cxnSp>
+        <p:nvCxnSpPr>
+          <p:cNvPr id="21" name="直線コネクタ 20">
+            <a:extLst>
+              <a:ext uri="{FF2B5EF4-FFF2-40B4-BE49-F238E27FC236}">
+                <a16:creationId xmlns:a16="http://schemas.microsoft.com/office/drawing/2014/main" id="{E1D674EB-5BD5-98E8-3D51-C961AC81D9B6}"/>
+              </a:ext>
+            </a:extLst>
+          </p:cNvPr>
+          <p:cNvCxnSpPr/>
+          <p:nvPr/>
+        </p:nvCxnSpPr>
+        <p:spPr>
+          <a:xfrm flipH="1">
+            <a:off x="6045200" y="1955800"/>
+            <a:ext cx="88900" cy="12700"/>
+          </a:xfrm>
+          <a:prstGeom prst="line">
+            <a:avLst/>
+          </a:prstGeom>
+          <a:ln w="10160">
+            <a:solidFill>
+              <a:srgbClr val="6E6E6E"/>
+            </a:solidFill>
+          </a:ln>
+        </p:spPr>
+        <p:style>
+          <a:lnRef idx="1">
+            <a:schemeClr val="accent1"/>
+          </a:lnRef>
+          <a:fillRef idx="0">
+            <a:schemeClr val="accent1"/>
+          </a:fillRef>
+          <a:effectRef idx="0">
+            <a:schemeClr val="accent1"/>
+          </a:effectRef>
+          <a:fontRef idx="minor">
+            <a:schemeClr val="tx1"/>
+          </a:fontRef>
+        </p:style>
+      </p:cxnSp>
+      <p:sp>
+        <p:nvSpPr>
+          <p:cNvPr id="22" name="テキスト ボックス 21">
+            <a:extLst>
+              <a:ext uri="{FF2B5EF4-FFF2-40B4-BE49-F238E27FC236}">
+                <a16:creationId xmlns:a16="http://schemas.microsoft.com/office/drawing/2014/main" id="{9C6A4673-330D-9E1B-A370-70978AE01CEA}"/>
               </a:ext>
             </a:extLst>
           </p:cNvPr>
@@ -14562,80 +14917,7 @@
         </p:nvSpPr>
         <p:spPr>
           <a:xfrm>
-            <a:off x="6350000" y="1854200"/>
-            <a:ext cx="1397000" cy="271869"/>
-          </a:xfrm>
-          <a:prstGeom prst="rect">
-            <a:avLst/>
-          </a:prstGeom>
-          <a:noFill/>
-        </p:spPr>
-        <p:txBody>
-          <a:bodyPr vert="horz" lIns="76200" tIns="50800" rIns="76200" bIns="50800" rtlCol="0">
-            <a:spAutoFit/>
-          </a:bodyPr>
-          <a:lstStyle/>
-          <a:p>
-            <a:r>
-              <a:rPr kumimoji="1" lang="en-US" altLang="ja-JP" sz="1100">
-                <a:solidFill>
-                  <a:srgbClr val="141414"/>
-                </a:solidFill>
-                <a:latin typeface="Yu Gothic" panose="020B0400000000000000" pitchFamily="50" charset="-128"/>
-              </a:rPr>
-              <a:t>(cos</a:t>
-            </a:r>
-            <a:r>
-              <a:rPr kumimoji="1" lang="el-GR" altLang="ja-JP" sz="1100">
-                <a:solidFill>
-                  <a:srgbClr val="141414"/>
-                </a:solidFill>
-                <a:latin typeface="Yu Gothic" panose="020B0400000000000000" pitchFamily="50" charset="-128"/>
-              </a:rPr>
-              <a:t>θ, </a:t>
-            </a:r>
-            <a:r>
-              <a:rPr kumimoji="1" lang="en-US" altLang="ja-JP" sz="1100">
-                <a:solidFill>
-                  <a:srgbClr val="141414"/>
-                </a:solidFill>
-                <a:latin typeface="Yu Gothic" panose="020B0400000000000000" pitchFamily="50" charset="-128"/>
-              </a:rPr>
-              <a:t>sin</a:t>
-            </a:r>
-            <a:r>
-              <a:rPr kumimoji="1" lang="el-GR" altLang="ja-JP" sz="1100">
-                <a:solidFill>
-                  <a:srgbClr val="141414"/>
-                </a:solidFill>
-                <a:latin typeface="Yu Gothic" panose="020B0400000000000000" pitchFamily="50" charset="-128"/>
-              </a:rPr>
-              <a:t>θ)</a:t>
-            </a:r>
-            <a:endParaRPr kumimoji="1" lang="ja-JP" altLang="en-US" sz="1100">
-              <a:solidFill>
-                <a:srgbClr val="141414"/>
-              </a:solidFill>
-              <a:latin typeface="Yu Gothic" panose="020B0400000000000000" pitchFamily="50" charset="-128"/>
-            </a:endParaRPr>
-          </a:p>
-        </p:txBody>
-      </p:sp>
-      <p:sp>
-        <p:nvSpPr>
-          <p:cNvPr id="16" name="テキスト ボックス 15">
-            <a:extLst>
-              <a:ext uri="{FF2B5EF4-FFF2-40B4-BE49-F238E27FC236}">
-                <a16:creationId xmlns:a16="http://schemas.microsoft.com/office/drawing/2014/main" id="{D7C7459D-3E06-99F1-7534-16CD74CE5E76}"/>
-              </a:ext>
-            </a:extLst>
-          </p:cNvPr>
-          <p:cNvSpPr txBox="1"/>
-          <p:nvPr/>
-        </p:nvSpPr>
-        <p:spPr>
-          <a:xfrm>
-            <a:off x="5511800" y="3035300"/>
+            <a:off x="5486400" y="3035300"/>
             <a:ext cx="762000" cy="271869"/>
           </a:xfrm>
           <a:prstGeom prst="rect">
@@ -14678,10 +14960,101 @@
       </p:sp>
       <p:sp>
         <p:nvSpPr>
-          <p:cNvPr id="17" name="テキスト ボックス 16">
+          <p:cNvPr id="23" name="正方形/長方形 22">
             <a:extLst>
               <a:ext uri="{FF2B5EF4-FFF2-40B4-BE49-F238E27FC236}">
-                <a16:creationId xmlns:a16="http://schemas.microsoft.com/office/drawing/2014/main" id="{38650B5A-3441-DE96-149F-7874E0E9EF0F}"/>
+                <a16:creationId xmlns:a16="http://schemas.microsoft.com/office/drawing/2014/main" id="{80E88D04-BAA8-F1CE-06A7-557E29AD744F}"/>
+              </a:ext>
+            </a:extLst>
+          </p:cNvPr>
+          <p:cNvSpPr/>
+          <p:nvPr/>
+        </p:nvSpPr>
+        <p:spPr>
+          <a:xfrm>
+            <a:off x="6146800" y="2387600"/>
+            <a:ext cx="609600" cy="266700"/>
+          </a:xfrm>
+          <a:prstGeom prst="rect">
+            <a:avLst/>
+          </a:prstGeom>
+          <a:solidFill>
+            <a:srgbClr val="FFFFFF">
+              <a:alpha val="92000"/>
+            </a:srgbClr>
+          </a:solidFill>
+          <a:ln w="25400" cap="flat" cmpd="sng" algn="ctr">
+            <a:noFill/>
+            <a:prstDash val="solid"/>
+          </a:ln>
+          <a:effectLst/>
+          <a:extLst>
+            <a:ext uri="{91240B29-F687-4F45-9708-019B960494DF}">
+              <a14:hiddenLine xmlns:a14="http://schemas.microsoft.com/office/drawing/2010/main" w="25400" cap="flat" cmpd="sng" algn="ctr">
+                <a:solidFill>
+                  <a:schemeClr val="accent1">
+                    <a:shade val="50000"/>
+                  </a:schemeClr>
+                </a:solidFill>
+                <a:prstDash val="solid"/>
+              </a14:hiddenLine>
+            </a:ext>
+          </a:extLst>
+        </p:spPr>
+        <p:style>
+          <a:lnRef idx="2">
+            <a:schemeClr val="accent1">
+              <a:shade val="50000"/>
+            </a:schemeClr>
+          </a:lnRef>
+          <a:fillRef idx="1">
+            <a:schemeClr val="accent1"/>
+          </a:fillRef>
+          <a:effectRef idx="0">
+            <a:schemeClr val="accent1"/>
+          </a:effectRef>
+          <a:fontRef idx="minor">
+            <a:schemeClr val="lt1"/>
+          </a:fontRef>
+        </p:style>
+        <p:txBody>
+          <a:bodyPr lIns="63500" tIns="25400" rIns="63500" bIns="25400" rtlCol="0" anchor="ctr"/>
+          <a:lstStyle/>
+          <a:p>
+            <a:pPr algn="ctr"/>
+            <a:r>
+              <a:rPr kumimoji="1" lang="en-US" altLang="ja-JP" sz="1100" b="1">
+                <a:solidFill>
+                  <a:srgbClr val="141414"/>
+                </a:solidFill>
+                <a:latin typeface="Yu Gothic" panose="020B0400000000000000" pitchFamily="50" charset="-128"/>
+              </a:rPr>
+              <a:t>sin</a:t>
+            </a:r>
+            <a:r>
+              <a:rPr kumimoji="1" lang="el-GR" altLang="ja-JP" sz="1100" b="1">
+                <a:solidFill>
+                  <a:srgbClr val="141414"/>
+                </a:solidFill>
+                <a:latin typeface="Yu Gothic" panose="020B0400000000000000" pitchFamily="50" charset="-128"/>
+              </a:rPr>
+              <a:t>θ</a:t>
+            </a:r>
+            <a:endParaRPr kumimoji="1" lang="ja-JP" altLang="en-US" sz="1100" b="1">
+              <a:solidFill>
+                <a:srgbClr val="141414"/>
+              </a:solidFill>
+              <a:latin typeface="Yu Gothic" panose="020B0400000000000000" pitchFamily="50" charset="-128"/>
+            </a:endParaRPr>
+          </a:p>
+        </p:txBody>
+      </p:sp>
+      <p:sp>
+        <p:nvSpPr>
+          <p:cNvPr id="24" name="テキスト ボックス 23">
+            <a:extLst>
+              <a:ext uri="{FF2B5EF4-FFF2-40B4-BE49-F238E27FC236}">
+                <a16:creationId xmlns:a16="http://schemas.microsoft.com/office/drawing/2014/main" id="{DBF5D189-E9D7-E9FE-E5B7-6B6FEC9B41D0}"/>
               </a:ext>
             </a:extLst>
           </p:cNvPr>
@@ -14690,8 +15063,8 @@
         </p:nvSpPr>
         <p:spPr>
           <a:xfrm>
-            <a:off x="6273800" y="2413000"/>
-            <a:ext cx="698500" cy="271869"/>
+            <a:off x="5384800" y="2654300"/>
+            <a:ext cx="304800" cy="302647"/>
           </a:xfrm>
           <a:prstGeom prst="rect">
             <a:avLst/>
@@ -14705,61 +15078,6 @@
           <a:lstStyle/>
           <a:p>
             <a:r>
-              <a:rPr kumimoji="1" lang="en-US" altLang="ja-JP" sz="1100">
-                <a:solidFill>
-                  <a:srgbClr val="141414"/>
-                </a:solidFill>
-                <a:latin typeface="Yu Gothic" panose="020B0400000000000000" pitchFamily="50" charset="-128"/>
-              </a:rPr>
-              <a:t>sin</a:t>
-            </a:r>
-            <a:r>
-              <a:rPr kumimoji="1" lang="el-GR" altLang="ja-JP" sz="1100">
-                <a:solidFill>
-                  <a:srgbClr val="141414"/>
-                </a:solidFill>
-                <a:latin typeface="Yu Gothic" panose="020B0400000000000000" pitchFamily="50" charset="-128"/>
-              </a:rPr>
-              <a:t>θ</a:t>
-            </a:r>
-            <a:endParaRPr kumimoji="1" lang="ja-JP" altLang="en-US" sz="1100">
-              <a:solidFill>
-                <a:srgbClr val="141414"/>
-              </a:solidFill>
-              <a:latin typeface="Yu Gothic" panose="020B0400000000000000" pitchFamily="50" charset="-128"/>
-            </a:endParaRPr>
-          </a:p>
-        </p:txBody>
-      </p:sp>
-      <p:sp>
-        <p:nvSpPr>
-          <p:cNvPr id="18" name="テキスト ボックス 17">
-            <a:extLst>
-              <a:ext uri="{FF2B5EF4-FFF2-40B4-BE49-F238E27FC236}">
-                <a16:creationId xmlns:a16="http://schemas.microsoft.com/office/drawing/2014/main" id="{D1E1207A-76AD-792B-963E-3E9D32578C61}"/>
-              </a:ext>
-            </a:extLst>
-          </p:cNvPr>
-          <p:cNvSpPr txBox="1"/>
-          <p:nvPr/>
-        </p:nvSpPr>
-        <p:spPr>
-          <a:xfrm>
-            <a:off x="5245100" y="2489200"/>
-            <a:ext cx="381000" cy="302647"/>
-          </a:xfrm>
-          <a:prstGeom prst="rect">
-            <a:avLst/>
-          </a:prstGeom>
-          <a:noFill/>
-        </p:spPr>
-        <p:txBody>
-          <a:bodyPr vert="horz" lIns="76200" tIns="50800" rIns="76200" bIns="50800" rtlCol="0">
-            <a:spAutoFit/>
-          </a:bodyPr>
-          <a:lstStyle/>
-          <a:p>
-            <a:r>
               <a:rPr kumimoji="1" lang="el-GR" altLang="ja-JP" sz="1300">
                 <a:solidFill>
                   <a:srgbClr val="141414"/>
@@ -14779,10 +15097,10 @@
       </p:sp>
       <p:sp>
         <p:nvSpPr>
-          <p:cNvPr id="19" name="テキスト ボックス 18">
+          <p:cNvPr id="25" name="テキスト ボックス 24">
             <a:extLst>
               <a:ext uri="{FF2B5EF4-FFF2-40B4-BE49-F238E27FC236}">
-                <a16:creationId xmlns:a16="http://schemas.microsoft.com/office/drawing/2014/main" id="{C1B0761D-F8AD-D9AB-96A0-615516101A56}"/>
+                <a16:creationId xmlns:a16="http://schemas.microsoft.com/office/drawing/2014/main" id="{DFF88F36-3FAF-738B-267A-B2D9D4BC93FF}"/>
               </a:ext>
             </a:extLst>
           </p:cNvPr>
@@ -14825,10 +15143,10 @@
       </p:sp>
       <p:sp>
         <p:nvSpPr>
-          <p:cNvPr id="20" name="テキスト ボックス 19">
+          <p:cNvPr id="26" name="テキスト ボックス 25">
             <a:extLst>
               <a:ext uri="{FF2B5EF4-FFF2-40B4-BE49-F238E27FC236}">
-                <a16:creationId xmlns:a16="http://schemas.microsoft.com/office/drawing/2014/main" id="{7DA44178-CE87-BFAE-C4B5-9356BB60DA71}"/>
+                <a16:creationId xmlns:a16="http://schemas.microsoft.com/office/drawing/2014/main" id="{CB2D488B-8EBF-C199-D1D2-2FA545CD9222}"/>
               </a:ext>
             </a:extLst>
           </p:cNvPr>
@@ -14871,10 +15189,10 @@
       </p:sp>
       <p:sp>
         <p:nvSpPr>
-          <p:cNvPr id="21" name="正方形/長方形 20">
+          <p:cNvPr id="27" name="正方形/長方形 26">
             <a:extLst>
               <a:ext uri="{FF2B5EF4-FFF2-40B4-BE49-F238E27FC236}">
-                <a16:creationId xmlns:a16="http://schemas.microsoft.com/office/drawing/2014/main" id="{FA6A2DCF-982C-196A-6F8D-CDE14B1AEA96}"/>
+                <a16:creationId xmlns:a16="http://schemas.microsoft.com/office/drawing/2014/main" id="{CF93ED92-FE80-6A15-E39B-24FC439DC82C}"/>
               </a:ext>
             </a:extLst>
           </p:cNvPr>
@@ -14883,8 +15201,8 @@
         </p:nvSpPr>
         <p:spPr>
           <a:xfrm>
-            <a:off x="6807200" y="1574800"/>
-            <a:ext cx="1930400" cy="2235200"/>
+            <a:off x="6959600" y="1574800"/>
+            <a:ext cx="1778000" cy="2235200"/>
           </a:xfrm>
           <a:prstGeom prst="rect">
             <a:avLst/>
@@ -14918,6 +15236,7 @@
           <a:bodyPr lIns="101600" tIns="76200" rIns="101600" bIns="76200" rtlCol="0" anchor="ctr"/>
           <a:lstStyle/>
           <a:p>
+            <a:pPr algn="ctr"/>
             <a:r>
               <a:rPr kumimoji="1" lang="ja-JP" altLang="en-US" sz="1000" b="1">
                 <a:solidFill>
@@ -15037,10 +15356,10 @@
       </p:sp>
       <p:sp>
         <p:nvSpPr>
-          <p:cNvPr id="22" name="正方形/長方形 21">
+          <p:cNvPr id="28" name="正方形/長方形 27">
             <a:extLst>
               <a:ext uri="{FF2B5EF4-FFF2-40B4-BE49-F238E27FC236}">
-                <a16:creationId xmlns:a16="http://schemas.microsoft.com/office/drawing/2014/main" id="{BC982EFC-915A-E4DE-DCC7-055F704B1F61}"/>
+                <a16:creationId xmlns:a16="http://schemas.microsoft.com/office/drawing/2014/main" id="{BDEE6B6D-6DEF-392A-1885-6899994D3C01}"/>
               </a:ext>
             </a:extLst>
           </p:cNvPr>
@@ -15241,7 +15560,7 @@
     </p:spTree>
     <p:extLst>
       <p:ext uri="{BB962C8B-B14F-4D97-AF65-F5344CB8AC3E}">
-        <p14:creationId xmlns:p14="http://schemas.microsoft.com/office/powerpoint/2010/main" val="2434187708"/>
+        <p14:creationId xmlns:p14="http://schemas.microsoft.com/office/powerpoint/2010/main" val="615355696"/>
       </p:ext>
     </p:extLst>
   </p:cSld>

</xml_diff>